<commit_message>
fix(conference): architecture slide response flow (U-shape: L6 Model Router -> L9 Verification -> ... -> L1 Streaming, right-to-left)
</commit_message>
<xml_diff>
--- a/conference/EASRA-LinkedIn-Carousel.pptx
+++ b/conference/EASRA-LinkedIn-Carousel.pptx
@@ -20634,7 +20634,7 @@
                 </a:solidFill>
                 <a:latin typeface="Segoe UI"/>
               </a:rPr>
-              <a:t>Routing · retries · circuit</a:t>
+              <a:t>Routing · retries</a:t>
             </a:r>
           </a:p>
         </p:txBody>
@@ -21487,11 +21487,11 @@
             <a:avLst/>
           </a:prstGeom>
           <a:solidFill>
-            <a:srgbClr val="FDECEA"/>
+            <a:srgbClr val="EAF3FF"/>
           </a:solidFill>
           <a:ln w="15875">
             <a:solidFill>
-              <a:srgbClr val="C0392B"/>
+              <a:srgbClr val="3B7DDD"/>
             </a:solidFill>
           </a:ln>
           <a:effectLst/>
@@ -21518,18 +21518,73 @@
             <a:r>
               <a:rPr sz="1100">
                 <a:solidFill>
-                  <a:srgbClr val="6B1A11"/>
-                </a:solidFill>
-                <a:latin typeface="Segoe UI"/>
-              </a:rPr>
-              <a:t>L9 Verification</a:t>
-            </a:r>
-          </a:p>
-        </p:txBody>
-      </p:sp>
-      <p:sp>
-        <p:nvSpPr>
-          <p:cNvPr id="36" name="Right Arrow 35"/>
+                  <a:srgbClr val="0B3D91"/>
+                </a:solidFill>
+                <a:latin typeface="Segoe UI"/>
+              </a:rPr>
+              <a:t>L1 Streaming</a:t>
+            </a:r>
+          </a:p>
+        </p:txBody>
+      </p:sp>
+      <p:sp>
+        <p:nvSpPr>
+          <p:cNvPr id="36" name="Rounded Rectangle 35"/>
+          <p:cNvSpPr/>
+          <p:nvPr/>
+        </p:nvSpPr>
+        <p:spPr>
+          <a:xfrm>
+            <a:off x="2554147" y="4965191"/>
+            <a:ext cx="2106091" cy="548640"/>
+          </a:xfrm>
+          <a:prstGeom prst="roundRect">
+            <a:avLst/>
+          </a:prstGeom>
+          <a:solidFill>
+            <a:srgbClr val="FFF6E5"/>
+          </a:solidFill>
+          <a:ln w="15875">
+            <a:solidFill>
+              <a:srgbClr val="B58900"/>
+            </a:solidFill>
+          </a:ln>
+          <a:effectLst/>
+        </p:spPr>
+        <p:style>
+          <a:lnRef idx="1">
+            <a:schemeClr val="accent1"/>
+          </a:lnRef>
+          <a:fillRef idx="3">
+            <a:schemeClr val="accent1"/>
+          </a:fillRef>
+          <a:effectRef idx="2">
+            <a:schemeClr val="accent1"/>
+          </a:effectRef>
+          <a:fontRef idx="minor">
+            <a:schemeClr val="lt1"/>
+          </a:fontRef>
+        </p:style>
+        <p:txBody>
+          <a:bodyPr rtlCol="0" anchor="ctr" lIns="73152" rIns="73152" tIns="36576" bIns="36576" wrap="square"/>
+          <a:lstStyle/>
+          <a:p>
+            <a:pPr algn="ctr"/>
+            <a:r>
+              <a:rPr sz="1100">
+                <a:solidFill>
+                  <a:srgbClr val="5A4200"/>
+                </a:solidFill>
+                <a:latin typeface="Segoe UI"/>
+              </a:rPr>
+              <a:t>Response Format</a:t>
+            </a:r>
+          </a:p>
+        </p:txBody>
+      </p:sp>
+      <p:sp>
+        <p:nvSpPr>
+          <p:cNvPr id="37" name="Left Arrow 36"/>
           <p:cNvSpPr/>
           <p:nvPr/>
         </p:nvSpPr>
@@ -21538,7 +21593,7 @@
             <a:off x="2407843" y="5138927"/>
             <a:ext cx="164592" cy="201168"/>
           </a:xfrm>
-          <a:prstGeom prst="rightArrow">
+          <a:prstGeom prst="leftArrow">
             <a:avLst/>
           </a:prstGeom>
           <a:solidFill>
@@ -21572,13 +21627,13 @@
       </p:sp>
       <p:sp>
         <p:nvSpPr>
-          <p:cNvPr id="37" name="Rounded Rectangle 36"/>
-          <p:cNvSpPr/>
-          <p:nvPr/>
-        </p:nvSpPr>
-        <p:spPr>
-          <a:xfrm>
-            <a:off x="2554147" y="4965191"/>
+          <p:cNvPr id="38" name="Rounded Rectangle 37"/>
+          <p:cNvSpPr/>
+          <p:nvPr/>
+        </p:nvSpPr>
+        <p:spPr>
+          <a:xfrm>
+            <a:off x="4788255" y="4965191"/>
             <a:ext cx="2106091" cy="548640"/>
           </a:xfrm>
           <a:prstGeom prst="roundRect">
@@ -21627,7 +21682,7 @@
       </p:sp>
       <p:sp>
         <p:nvSpPr>
-          <p:cNvPr id="38" name="Right Arrow 37"/>
+          <p:cNvPr id="39" name="Left Arrow 38"/>
           <p:cNvSpPr/>
           <p:nvPr/>
         </p:nvSpPr>
@@ -21636,7 +21691,7 @@
             <a:off x="4641951" y="5138927"/>
             <a:ext cx="164592" cy="201168"/>
           </a:xfrm>
-          <a:prstGeom prst="rightArrow">
+          <a:prstGeom prst="leftArrow">
             <a:avLst/>
           </a:prstGeom>
           <a:solidFill>
@@ -21670,24 +21725,24 @@
       </p:sp>
       <p:sp>
         <p:nvSpPr>
-          <p:cNvPr id="39" name="Rounded Rectangle 38"/>
-          <p:cNvSpPr/>
-          <p:nvPr/>
-        </p:nvSpPr>
-        <p:spPr>
-          <a:xfrm>
-            <a:off x="4788255" y="4965191"/>
+          <p:cNvPr id="40" name="Rounded Rectangle 39"/>
+          <p:cNvSpPr/>
+          <p:nvPr/>
+        </p:nvSpPr>
+        <p:spPr>
+          <a:xfrm>
+            <a:off x="7022363" y="4965191"/>
             <a:ext cx="2106091" cy="548640"/>
           </a:xfrm>
           <a:prstGeom prst="roundRect">
             <a:avLst/>
           </a:prstGeom>
           <a:solidFill>
-            <a:srgbClr val="FFF6E5"/>
+            <a:srgbClr val="FDECEA"/>
           </a:solidFill>
           <a:ln w="15875">
             <a:solidFill>
-              <a:srgbClr val="B58900"/>
+              <a:srgbClr val="C0392B"/>
             </a:solidFill>
           </a:ln>
           <a:effectLst/>
@@ -21714,18 +21769,18 @@
             <a:r>
               <a:rPr sz="1100">
                 <a:solidFill>
-                  <a:srgbClr val="5A4200"/>
-                </a:solidFill>
-                <a:latin typeface="Segoe UI"/>
-              </a:rPr>
-              <a:t>Response Format</a:t>
-            </a:r>
-          </a:p>
-        </p:txBody>
-      </p:sp>
-      <p:sp>
-        <p:nvSpPr>
-          <p:cNvPr id="40" name="Right Arrow 39"/>
+                  <a:srgbClr val="6B1A11"/>
+                </a:solidFill>
+                <a:latin typeface="Segoe UI"/>
+              </a:rPr>
+              <a:t>L9 Verification</a:t>
+            </a:r>
+          </a:p>
+        </p:txBody>
+      </p:sp>
+      <p:sp>
+        <p:nvSpPr>
+          <p:cNvPr id="41" name="Left Arrow 40"/>
           <p:cNvSpPr/>
           <p:nvPr/>
         </p:nvSpPr>
@@ -21734,7 +21789,7 @@
             <a:off x="6876059" y="5138927"/>
             <a:ext cx="164592" cy="201168"/>
           </a:xfrm>
-          <a:prstGeom prst="rightArrow">
+          <a:prstGeom prst="leftArrow">
             <a:avLst/>
           </a:prstGeom>
           <a:solidFill>
@@ -21768,68 +21823,13 @@
       </p:sp>
       <p:sp>
         <p:nvSpPr>
-          <p:cNvPr id="41" name="Rounded Rectangle 40"/>
-          <p:cNvSpPr/>
-          <p:nvPr/>
-        </p:nvSpPr>
-        <p:spPr>
-          <a:xfrm>
-            <a:off x="7022363" y="4965191"/>
-            <a:ext cx="2106091" cy="548640"/>
-          </a:xfrm>
-          <a:prstGeom prst="roundRect">
-            <a:avLst/>
-          </a:prstGeom>
-          <a:solidFill>
-            <a:srgbClr val="EAF3FF"/>
-          </a:solidFill>
-          <a:ln w="15875">
-            <a:solidFill>
-              <a:srgbClr val="3B7DDD"/>
-            </a:solidFill>
-          </a:ln>
-          <a:effectLst/>
-        </p:spPr>
-        <p:style>
-          <a:lnRef idx="1">
-            <a:schemeClr val="accent1"/>
-          </a:lnRef>
-          <a:fillRef idx="3">
-            <a:schemeClr val="accent1"/>
-          </a:fillRef>
-          <a:effectRef idx="2">
-            <a:schemeClr val="accent1"/>
-          </a:effectRef>
-          <a:fontRef idx="minor">
-            <a:schemeClr val="lt1"/>
-          </a:fontRef>
-        </p:style>
-        <p:txBody>
-          <a:bodyPr rtlCol="0" anchor="ctr" lIns="73152" rIns="73152" tIns="36576" bIns="36576" wrap="square"/>
-          <a:lstStyle/>
-          <a:p>
-            <a:pPr algn="ctr"/>
-            <a:r>
-              <a:rPr sz="1100">
-                <a:solidFill>
-                  <a:srgbClr val="0B3D91"/>
-                </a:solidFill>
-                <a:latin typeface="Segoe UI"/>
-              </a:rPr>
-              <a:t>L1 Streaming</a:t>
-            </a:r>
-          </a:p>
-        </p:txBody>
-      </p:sp>
-      <p:sp>
-        <p:nvSpPr>
           <p:cNvPr id="42" name="Down Arrow 41"/>
           <p:cNvSpPr/>
           <p:nvPr/>
         </p:nvSpPr>
         <p:spPr>
           <a:xfrm>
-            <a:off x="4623663" y="4709159"/>
+            <a:off x="7974825" y="4709159"/>
             <a:ext cx="201168" cy="201168"/>
           </a:xfrm>
           <a:prstGeom prst="downArrow">

</xml_diff>

<commit_message>
fix(conference): AI-GW->Router arrow visibility + async connector now terminates at Event Bus (not Retry Queue)
</commit_message>
<xml_diff>
--- a/conference/EASRA-LinkedIn-Carousel.pptx
+++ b/conference/EASRA-LinkedIn-Carousel.pptx
@@ -20702,7 +20702,7 @@
         </p:nvSpPr>
         <p:spPr>
           <a:xfrm>
-            <a:off x="8190920" y="1691640"/>
+            <a:off x="8559178" y="1691640"/>
             <a:ext cx="201168" cy="292608"/>
           </a:xfrm>
           <a:prstGeom prst="downArrow">
@@ -22245,9 +22245,9 @@
           <p:nvPr/>
         </p:nvCxnSpPr>
         <p:spPr>
-          <a:xfrm>
-            <a:off x="9128455" y="3753611"/>
-            <a:ext cx="365760" cy="0"/>
+          <a:xfrm flipV="1">
+            <a:off x="9311335" y="1399032"/>
+            <a:ext cx="0" cy="1417320"/>
           </a:xfrm>
           <a:prstGeom prst="line">
             <a:avLst/>
@@ -22274,9 +22274,45 @@
           </a:fontRef>
         </p:style>
       </p:cxnSp>
-      <p:sp>
-        <p:nvSpPr>
-          <p:cNvPr id="50" name="Rounded Rectangle 49"/>
+      <p:cxnSp>
+        <p:nvCxnSpPr>
+          <p:cNvPr id="50" name="Connector 49"/>
+          <p:cNvCxnSpPr/>
+          <p:nvPr/>
+        </p:nvCxnSpPr>
+        <p:spPr>
+          <a:xfrm>
+            <a:off x="9311335" y="1399032"/>
+            <a:ext cx="182880" cy="0"/>
+          </a:xfrm>
+          <a:prstGeom prst="line">
+            <a:avLst/>
+          </a:prstGeom>
+          <a:ln w="19050">
+            <a:solidFill>
+              <a:srgbClr val="B58900"/>
+            </a:solidFill>
+            <a:prstDash val="dash"/>
+          </a:ln>
+        </p:spPr>
+        <p:style>
+          <a:lnRef idx="2">
+            <a:schemeClr val="accent1"/>
+          </a:lnRef>
+          <a:fillRef idx="0">
+            <a:schemeClr val="accent1"/>
+          </a:fillRef>
+          <a:effectRef idx="1">
+            <a:schemeClr val="accent1"/>
+          </a:effectRef>
+          <a:fontRef idx="minor">
+            <a:schemeClr val="tx1"/>
+          </a:fontRef>
+        </p:style>
+      </p:cxnSp>
+      <p:sp>
+        <p:nvSpPr>
+          <p:cNvPr id="51" name="Rounded Rectangle 50"/>
           <p:cNvSpPr/>
           <p:nvPr/>
         </p:nvSpPr>
@@ -22343,7 +22379,7 @@
       </p:sp>
       <p:sp>
         <p:nvSpPr>
-          <p:cNvPr id="51" name="Rounded Rectangle 50"/>
+          <p:cNvPr id="52" name="Rounded Rectangle 51"/>
           <p:cNvSpPr/>
           <p:nvPr/>
         </p:nvSpPr>
@@ -22410,7 +22446,7 @@
       </p:sp>
       <p:sp>
         <p:nvSpPr>
-          <p:cNvPr id="52" name="Rounded Rectangle 51"/>
+          <p:cNvPr id="53" name="Rounded Rectangle 52"/>
           <p:cNvSpPr/>
           <p:nvPr/>
         </p:nvSpPr>
@@ -22477,7 +22513,7 @@
       </p:sp>
       <p:sp>
         <p:nvSpPr>
-          <p:cNvPr id="53" name="TextBox 52"/>
+          <p:cNvPr id="54" name="TextBox 53"/>
           <p:cNvSpPr txBox="1"/>
           <p:nvPr/>
         </p:nvSpPr>

</xml_diff>

<commit_message>
polish(v4): reviewer feedback - 'reference architecture' not 'standard' + L12 renamed to AI Platform Engineering + Bronze/Silver/Gold/Platinum conformance
Reviewer round 3 polish before publish:

- CAROUSEL: drop 'standard' claim (cover badge, hero subtitle, CTA slide). Now reads 'Open Reference Architecture'. Keeps factual 'Standards-aligned' where it means aligned WITH external standards (NIST/ISO/EU AI Act/OWASP/MITRE).

- CAROUSEL: rename layer L12 'LLMOps & Delivery' -> 'AI Platform Engineering' (future-proofs for multimodal, diffusion, speech, reasoning models). Applied on layer index, on the AI Platform slide, on ADR slide references, and on the three-planes bullet.

- README: drop 'open architecture standard' claim -> 'open reference architecture'.

- ROADMAP: add Bronze / Silver / Gold / Platinum conformance levels section (replaces earlier Baseline/Regulated/Safety-critical framing).
</commit_message>
<xml_diff>
--- a/conference/EASRA-LinkedIn-Carousel.pptx
+++ b/conference/EASRA-LinkedIn-Carousel.pptx
@@ -3221,7 +3221,7 @@
                 </a:solidFill>
                 <a:latin typeface="Segoe UI"/>
               </a:rPr>
-              <a:t>OPEN ARCHITECTURE STANDARD  ·  v0.1.0</a:t>
+              <a:t>OPEN REFERENCE ARCHITECTURE  ·  v0.1.0</a:t>
             </a:r>
           </a:p>
         </p:txBody>
@@ -3326,7 +3326,7 @@
                 </a:solidFill>
                 <a:latin typeface="Segoe UI"/>
               </a:rPr>
-              <a:t>The open standard for production-grade Enterprise AI.</a:t>
+              <a:t>The open reference architecture for production-grade Enterprise AI.</a:t>
             </a:r>
           </a:p>
         </p:txBody>
@@ -6269,7 +6269,7 @@
                 </a:solidFill>
                 <a:latin typeface="Segoe UI"/>
               </a:rPr>
-              <a:t>•  LLMOps eval &amp; benchmarks</a:t>
+              <a:t>•  AI Platform eval &amp; benchmarks</a:t>
             </a:r>
           </a:p>
           <a:p>
@@ -8951,7 +8951,7 @@
                 </a:solidFill>
                 <a:latin typeface="Segoe UI"/>
               </a:rPr>
-              <a:t>L12 · LLMOps &amp; Delivery</a:t>
+              <a:t>L12 · AI Platform Engineering</a:t>
             </a:r>
           </a:p>
         </p:txBody>
@@ -8986,7 +8986,7 @@
                 </a:solidFill>
                 <a:latin typeface="Segoe UI"/>
               </a:rPr>
-              <a:t>Traditional CI/CD is not enough. LLMOps adds prompt tests, eval gates, model registry, canary + shadow, cost guardrails.</a:t>
+              <a:t>Traditional CI/CD is not enough. AI Platform Engineering adds prompt tests, eval gates, model registry, canary + shadow, cost guardrails.</a:t>
             </a:r>
           </a:p>
         </p:txBody>
@@ -11436,7 +11436,7 @@
                 </a:solidFill>
                 <a:latin typeface="Segoe UI"/>
               </a:rPr>
-              <a:t>Mapped in EASRA at:  L14 · L12 LLMOps · L15 Value</a:t>
+              <a:t>Mapped in EASRA at:  L14 · L12 AI Platform · L15 Value</a:t>
             </a:r>
           </a:p>
         </p:txBody>
@@ -12148,7 +12148,7 @@
                 </a:solidFill>
                 <a:latin typeface="Segoe UI"/>
               </a:rPr>
-              <a:t>Every consequential architectural choice in EASRA is recorded as an ADR. Not a deliverable — a first-class artefact of the standard.</a:t>
+              <a:t>Every consequential architectural choice in EASRA is recorded as an ADR. Not a deliverable — a first-class artefact of the framework.</a:t>
             </a:r>
           </a:p>
         </p:txBody>
@@ -14657,7 +14657,7 @@
                 </a:solidFill>
                 <a:latin typeface="Segoe UI"/>
               </a:rPr>
-              <a:t>An open architecture standard for Enterprise AI.</a:t>
+              <a:t>An open reference architecture for Enterprise AI.</a:t>
             </a:r>
           </a:p>
         </p:txBody>
@@ -19498,7 +19498,7 @@
                 </a:solidFill>
                 <a:latin typeface="Segoe UI"/>
               </a:rPr>
-              <a:t>LLMOps &amp; Delivery</a:t>
+              <a:t>AI Platform Engineering</a:t>
             </a:r>
           </a:p>
           <a:p>

</xml_diff>

<commit_message>
feat(conference): close the U-shape - L1 Streaming -> User loop + Event Bus -> Async Workers arrow
</commit_message>
<xml_diff>
--- a/conference/EASRA-LinkedIn-Carousel.pptx
+++ b/conference/EASRA-LinkedIn-Carousel.pptx
@@ -21899,9 +21899,124 @@
           </a:p>
         </p:txBody>
       </p:sp>
-      <p:sp>
-        <p:nvSpPr>
-          <p:cNvPr id="44" name="Rounded Rectangle 43"/>
+      <p:cxnSp>
+        <p:nvCxnSpPr>
+          <p:cNvPr id="44" name="Connector 43"/>
+          <p:cNvCxnSpPr/>
+          <p:nvPr/>
+        </p:nvCxnSpPr>
+        <p:spPr>
+          <a:xfrm flipH="1">
+            <a:off x="128016" y="5239511"/>
+            <a:ext cx="192024" cy="0"/>
+          </a:xfrm>
+          <a:prstGeom prst="line">
+            <a:avLst/>
+          </a:prstGeom>
+          <a:ln w="19050">
+            <a:solidFill>
+              <a:srgbClr val="16A085"/>
+            </a:solidFill>
+            <a:prstDash val="dash"/>
+          </a:ln>
+        </p:spPr>
+        <p:style>
+          <a:lnRef idx="2">
+            <a:schemeClr val="accent1"/>
+          </a:lnRef>
+          <a:fillRef idx="0">
+            <a:schemeClr val="accent1"/>
+          </a:fillRef>
+          <a:effectRef idx="1">
+            <a:schemeClr val="accent1"/>
+          </a:effectRef>
+          <a:fontRef idx="minor">
+            <a:schemeClr val="tx1"/>
+          </a:fontRef>
+        </p:style>
+      </p:cxnSp>
+      <p:cxnSp>
+        <p:nvCxnSpPr>
+          <p:cNvPr id="45" name="Connector 44"/>
+          <p:cNvCxnSpPr/>
+          <p:nvPr/>
+        </p:nvCxnSpPr>
+        <p:spPr>
+          <a:xfrm flipV="1">
+            <a:off x="128016" y="1421892"/>
+            <a:ext cx="0" cy="3817619"/>
+          </a:xfrm>
+          <a:prstGeom prst="line">
+            <a:avLst/>
+          </a:prstGeom>
+          <a:ln w="19050">
+            <a:solidFill>
+              <a:srgbClr val="16A085"/>
+            </a:solidFill>
+            <a:prstDash val="dash"/>
+          </a:ln>
+        </p:spPr>
+        <p:style>
+          <a:lnRef idx="2">
+            <a:schemeClr val="accent1"/>
+          </a:lnRef>
+          <a:fillRef idx="0">
+            <a:schemeClr val="accent1"/>
+          </a:fillRef>
+          <a:effectRef idx="1">
+            <a:schemeClr val="accent1"/>
+          </a:effectRef>
+          <a:fontRef idx="minor">
+            <a:schemeClr val="tx1"/>
+          </a:fontRef>
+        </p:style>
+      </p:cxnSp>
+      <p:sp>
+        <p:nvSpPr>
+          <p:cNvPr id="46" name="Right Arrow 45"/>
+          <p:cNvSpPr/>
+          <p:nvPr/>
+        </p:nvSpPr>
+        <p:spPr>
+          <a:xfrm>
+            <a:off x="128016" y="1339596"/>
+            <a:ext cx="192024" cy="164592"/>
+          </a:xfrm>
+          <a:prstGeom prst="rightArrow">
+            <a:avLst/>
+          </a:prstGeom>
+          <a:solidFill>
+            <a:srgbClr val="16A085"/>
+          </a:solidFill>
+          <a:ln w="3175">
+            <a:solidFill>
+              <a:srgbClr val="16A085"/>
+            </a:solidFill>
+          </a:ln>
+        </p:spPr>
+        <p:style>
+          <a:lnRef idx="1">
+            <a:schemeClr val="accent1"/>
+          </a:lnRef>
+          <a:fillRef idx="3">
+            <a:schemeClr val="accent1"/>
+          </a:fillRef>
+          <a:effectRef idx="2">
+            <a:schemeClr val="accent1"/>
+          </a:effectRef>
+          <a:fontRef idx="minor">
+            <a:schemeClr val="lt1"/>
+          </a:fontRef>
+        </p:style>
+        <p:txBody>
+          <a:bodyPr rtlCol="0" anchor="ctr"/>
+          <a:lstStyle/>
+          <a:p/>
+        </p:txBody>
+      </p:sp>
+      <p:sp>
+        <p:nvSpPr>
+          <p:cNvPr id="47" name="Rounded Rectangle 46"/>
           <p:cNvSpPr/>
           <p:nvPr/>
         </p:nvSpPr>
@@ -21968,7 +22083,7 @@
       </p:sp>
       <p:sp>
         <p:nvSpPr>
-          <p:cNvPr id="45" name="Rounded Rectangle 44"/>
+          <p:cNvPr id="48" name="Rounded Rectangle 47"/>
           <p:cNvSpPr/>
           <p:nvPr/>
         </p:nvSpPr>
@@ -22036,7 +22151,7 @@
       </p:sp>
       <p:sp>
         <p:nvSpPr>
-          <p:cNvPr id="46" name="Rounded Rectangle 45"/>
+          <p:cNvPr id="49" name="Rounded Rectangle 48"/>
           <p:cNvSpPr/>
           <p:nvPr/>
         </p:nvSpPr>
@@ -22104,7 +22219,7 @@
       </p:sp>
       <p:sp>
         <p:nvSpPr>
-          <p:cNvPr id="47" name="Rounded Rectangle 46"/>
+          <p:cNvPr id="50" name="Rounded Rectangle 49"/>
           <p:cNvSpPr/>
           <p:nvPr/>
         </p:nvSpPr>
@@ -22172,7 +22287,7 @@
       </p:sp>
       <p:sp>
         <p:nvSpPr>
-          <p:cNvPr id="48" name="Rounded Rectangle 47"/>
+          <p:cNvPr id="51" name="Rounded Rectangle 50"/>
           <p:cNvSpPr/>
           <p:nvPr/>
         </p:nvSpPr>
@@ -22238,9 +22353,52 @@
           </a:p>
         </p:txBody>
       </p:sp>
+      <p:sp>
+        <p:nvSpPr>
+          <p:cNvPr id="52" name="Down Arrow 51"/>
+          <p:cNvSpPr/>
+          <p:nvPr/>
+        </p:nvSpPr>
+        <p:spPr>
+          <a:xfrm>
+            <a:off x="10600639" y="1636776"/>
+            <a:ext cx="164592" cy="118872"/>
+          </a:xfrm>
+          <a:prstGeom prst="downArrow">
+            <a:avLst/>
+          </a:prstGeom>
+          <a:solidFill>
+            <a:srgbClr val="B58900"/>
+          </a:solidFill>
+          <a:ln w="3175">
+            <a:solidFill>
+              <a:srgbClr val="B58900"/>
+            </a:solidFill>
+          </a:ln>
+        </p:spPr>
+        <p:style>
+          <a:lnRef idx="1">
+            <a:schemeClr val="accent1"/>
+          </a:lnRef>
+          <a:fillRef idx="3">
+            <a:schemeClr val="accent1"/>
+          </a:fillRef>
+          <a:effectRef idx="2">
+            <a:schemeClr val="accent1"/>
+          </a:effectRef>
+          <a:fontRef idx="minor">
+            <a:schemeClr val="lt1"/>
+          </a:fontRef>
+        </p:style>
+        <p:txBody>
+          <a:bodyPr rtlCol="0" anchor="ctr"/>
+          <a:lstStyle/>
+          <a:p/>
+        </p:txBody>
+      </p:sp>
       <p:cxnSp>
         <p:nvCxnSpPr>
-          <p:cNvPr id="49" name="Connector 48"/>
+          <p:cNvPr id="53" name="Connector 52"/>
           <p:cNvCxnSpPr/>
           <p:nvPr/>
         </p:nvCxnSpPr>
@@ -22276,7 +22434,7 @@
       </p:cxnSp>
       <p:cxnSp>
         <p:nvCxnSpPr>
-          <p:cNvPr id="50" name="Connector 49"/>
+          <p:cNvPr id="54" name="Connector 53"/>
           <p:cNvCxnSpPr/>
           <p:nvPr/>
         </p:nvCxnSpPr>
@@ -22312,7 +22470,7 @@
       </p:cxnSp>
       <p:sp>
         <p:nvSpPr>
-          <p:cNvPr id="51" name="Rounded Rectangle 50"/>
+          <p:cNvPr id="55" name="Rounded Rectangle 54"/>
           <p:cNvSpPr/>
           <p:nvPr/>
         </p:nvSpPr>
@@ -22379,7 +22537,7 @@
       </p:sp>
       <p:sp>
         <p:nvSpPr>
-          <p:cNvPr id="52" name="Rounded Rectangle 51"/>
+          <p:cNvPr id="56" name="Rounded Rectangle 55"/>
           <p:cNvSpPr/>
           <p:nvPr/>
         </p:nvSpPr>
@@ -22446,7 +22604,7 @@
       </p:sp>
       <p:sp>
         <p:nvSpPr>
-          <p:cNvPr id="53" name="Rounded Rectangle 52"/>
+          <p:cNvPr id="57" name="Rounded Rectangle 56"/>
           <p:cNvSpPr/>
           <p:nvPr/>
         </p:nvSpPr>
@@ -22513,7 +22671,7 @@
       </p:sp>
       <p:sp>
         <p:nvSpPr>
-          <p:cNvPr id="54" name="TextBox 53"/>
+          <p:cNvPr id="58" name="TextBox 57"/>
           <p:cNvSpPr txBox="1"/>
           <p:nvPr/>
         </p:nvSpPr>

</xml_diff>